<commit_message>
Changed title to pptx
</commit_message>
<xml_diff>
--- a/LabBook_40.pptx
+++ b/LabBook_40.pptx
@@ -3144,14 +3144,14 @@
                 <a:latin typeface="Lucida Sans"/>
                 <a:cs typeface="Lucida Sans"/>
               </a:rPr>
-              <a:t>Lab Book 3.0 Circuits and Compact </a:t>
-            </a:r>
-            <a:r>
-              <a:rPr lang="es-ES" sz="3200" b="1" dirty="0" err="1">
+              <a:t>Lab Book 4.0 </a:t>
+            </a:r>
+            <a:r>
+              <a:rPr lang="es-ES" sz="3200" b="1">
                 <a:latin typeface="Lucida Sans"/>
                 <a:cs typeface="Lucida Sans"/>
               </a:rPr>
-              <a:t>Models</a:t>
+              <a:t>Layout</a:t>
             </a:r>
             <a:endParaRPr sz="3200" dirty="0">
               <a:latin typeface="Lucida Sans"/>

</xml_diff>